<commit_message>
Slides: badged PPTX of sd-04-027
</commit_message>
<xml_diff>
--- a/system-design-101/vi/lessons/sd-04-027/slides/sd-04-027.pptx
+++ b/system-design-101/vi/lessons/sd-04-027/slides/sd-04-027.pptx
@@ -5852,10 +5852,10 @@
                 <a:ea typeface="Be Vietnam Pro" pitchFamily="34" charset="-122"/>
                 <a:cs typeface="Be Vietnam Pro" pitchFamily="34" charset="-120"/>
               </a:rPr>
-              <a:t>CHẶNG 1</a:t>
-            </a:r>
-            <a:r>
-              <a:rPr lang="en-US" sz="1950" b="1" spc="175" kern="0" dirty="0">
+              <a:t>CHẶNG 1,</a:t>
+            </a:r>
+            <a:r>
+              <a:rPr lang="en-US" sz="1950" b="1" spc="222" kern="0" dirty="0">
                 <a:solidFill>
                   <a:srgbClr val="E8472B"/>
                 </a:solidFill>
@@ -5863,7 +5863,7 @@
                 <a:ea typeface="Be Vietnam Pro" pitchFamily="34" charset="-122"/>
                 <a:cs typeface="Be Vietnam Pro" pitchFamily="34" charset="-120"/>
               </a:rPr>
-              <a:t> VÀ</a:t>
+              <a:t> 2</a:t>
             </a:r>
             <a:r>
               <a:rPr lang="en-US" sz="1950" b="1" spc="221" kern="0" dirty="0">
@@ -5874,10 +5874,10 @@
                 <a:ea typeface="Be Vietnam Pro" pitchFamily="34" charset="-122"/>
                 <a:cs typeface="Be Vietnam Pro" pitchFamily="34" charset="-120"/>
               </a:rPr>
-              <a:t> 2</a:t>
-            </a:r>
-            <a:r>
-              <a:rPr lang="en-US" sz="1950" b="1" spc="222" kern="0" dirty="0">
+              <a:t> ·</a:t>
+            </a:r>
+            <a:r>
+              <a:rPr lang="en-US" sz="1950" b="1" spc="223" kern="0" dirty="0">
                 <a:solidFill>
                   <a:srgbClr val="E8472B"/>
                 </a:solidFill>
@@ -5885,10 +5885,10 @@
                 <a:ea typeface="Be Vietnam Pro" pitchFamily="34" charset="-122"/>
                 <a:cs typeface="Be Vietnam Pro" pitchFamily="34" charset="-120"/>
               </a:rPr>
-              <a:t> ·</a:t>
-            </a:r>
-            <a:r>
-              <a:rPr lang="en-US" sz="1950" b="1" spc="223" kern="0" dirty="0">
+              <a:t> KẾT</a:t>
+            </a:r>
+            <a:r>
+              <a:rPr lang="en-US" sz="1950" b="1" spc="225" kern="0" dirty="0">
                 <a:solidFill>
                   <a:srgbClr val="E8472B"/>
                 </a:solidFill>
@@ -5896,7 +5896,29 @@
                 <a:ea typeface="Be Vietnam Pro" pitchFamily="34" charset="-122"/>
                 <a:cs typeface="Be Vietnam Pro" pitchFamily="34" charset="-120"/>
               </a:rPr>
-              <a:t> KẾT</a:t>
+              <a:t> NỐI, PHÂN</a:t>
+            </a:r>
+            <a:r>
+              <a:rPr lang="en-US" sz="1950" b="1" spc="226" kern="0" dirty="0">
+                <a:solidFill>
+                  <a:srgbClr val="E8472B"/>
+                </a:solidFill>
+                <a:latin typeface="Be Vietnam Pro" pitchFamily="34" charset="0"/>
+                <a:ea typeface="Be Vietnam Pro" pitchFamily="34" charset="-122"/>
+                <a:cs typeface="Be Vietnam Pro" pitchFamily="34" charset="-120"/>
+              </a:rPr>
+              <a:t> TÍCH</a:t>
+            </a:r>
+            <a:r>
+              <a:rPr lang="en-US" sz="1950" b="1" spc="224" kern="0" dirty="0">
+                <a:solidFill>
+                  <a:srgbClr val="E8472B"/>
+                </a:solidFill>
+                <a:latin typeface="Be Vietnam Pro" pitchFamily="34" charset="0"/>
+                <a:ea typeface="Be Vietnam Pro" pitchFamily="34" charset="-122"/>
+                <a:cs typeface="Be Vietnam Pro" pitchFamily="34" charset="-120"/>
+              </a:rPr>
+              <a:t> CÚ</a:t>
             </a:r>
             <a:r>
               <a:rPr lang="en-US" sz="1950" b="1" spc="225" kern="0" dirty="0">
@@ -5907,7 +5929,7 @@
                 <a:ea typeface="Be Vietnam Pro" pitchFamily="34" charset="-122"/>
                 <a:cs typeface="Be Vietnam Pro" pitchFamily="34" charset="-120"/>
               </a:rPr>
-              <a:t> NỐI, PHÂN TÍCH CÚ PHÁP</a:t>
+              <a:t> PHÁP</a:t>
             </a:r>
             <a:endParaRPr lang="en-US" sz="1950" dirty="0"/>
           </a:p>

</xml_diff>